<commit_message>
docs(docs): Updates slides and notes for the TAC meeting.
Signed-off-by: Marvin Hansen <marvin.hansen@gmail.com>
</commit_message>
<xml_diff>
--- a/docs/LF/slides/LF_2026/DeepCausality_TAC_2026.pptx
+++ b/docs/LF/slides/LF_2026/DeepCausality_TAC_2026.pptx
@@ -25,7 +25,7 @@
     <p:sldId id="278" r:id="rId16"/>
   </p:sldIdLst>
   <p:sldSz cx="12192000" cy="6858000"/>
-  <p:notesSz cx="6858000" cy="9144000"/>
+  <p:notesSz cx="9144000" cy="6858000"/>
   <p:defaultTextStyle>
     <a:defPPr>
       <a:defRPr lang="en-US"/>
@@ -9622,7 +9622,43 @@
                 </a:solidFill>
                 <a:latin typeface="Geist"/>
               </a:rPr>
-              <a:t>In September 2023, at the point of the Sandbox proposal, the </a:t>
+              <a:t>In September 2023, at the </a:t>
+            </a:r>
+            <a:r>
+              <a:rPr lang="en-US" sz="1400" dirty="0">
+                <a:solidFill>
+                  <a:srgbClr val="AAB3BD"/>
+                </a:solidFill>
+                <a:latin typeface="Geist"/>
+              </a:rPr>
+              <a:t>LF </a:t>
+            </a:r>
+            <a:r>
+              <a:rPr sz="1400" dirty="0">
+                <a:solidFill>
+                  <a:srgbClr val="AAB3BD"/>
+                </a:solidFill>
+                <a:latin typeface="Geist"/>
+              </a:rPr>
+              <a:t>Sandbox </a:t>
+            </a:r>
+            <a:r>
+              <a:rPr lang="en-US" sz="1400" dirty="0">
+                <a:solidFill>
+                  <a:srgbClr val="AAB3BD"/>
+                </a:solidFill>
+                <a:latin typeface="Geist"/>
+              </a:rPr>
+              <a:t>admission</a:t>
+            </a:r>
+            <a:r>
+              <a:rPr sz="1400" dirty="0">
+                <a:solidFill>
+                  <a:srgbClr val="AAB3BD"/>
+                </a:solidFill>
+                <a:latin typeface="Geist"/>
+              </a:rPr>
+              <a:t>, the </a:t>
             </a:r>
             <a:r>
               <a:rPr lang="en-US" sz="1400" dirty="0">
@@ -11031,13 +11067,31 @@
               </a:spcAft>
             </a:pPr>
             <a:r>
-              <a:rPr sz="950" spc="76">
+              <a:rPr sz="950" spc="76" dirty="0">
                 <a:solidFill>
                   <a:srgbClr val="5CD4E1"/>
                 </a:solidFill>
                 <a:latin typeface="JetBrains Mono Medium"/>
               </a:rPr>
-              <a:t>ZERO-DEPENDENCY CRATES</a:t>
+              <a:t>ZERO-</a:t>
+            </a:r>
+            <a:r>
+              <a:rPr lang="en-US" sz="950" spc="76" dirty="0">
+                <a:solidFill>
+                  <a:srgbClr val="5CD4E1"/>
+                </a:solidFill>
+                <a:latin typeface="JetBrains Mono Medium"/>
+              </a:rPr>
+              <a:t>Ext. </a:t>
+            </a:r>
+            <a:r>
+              <a:rPr sz="950" spc="76" dirty="0">
+                <a:solidFill>
+                  <a:srgbClr val="5CD4E1"/>
+                </a:solidFill>
+                <a:latin typeface="JetBrains Mono Medium"/>
+              </a:rPr>
+              <a:t>DEPENDENCY CRATES</a:t>
             </a:r>
           </a:p>
         </p:txBody>

</xml_diff>